<commit_message>
Add the submitting team to the README, the documentation and the deck
Harish HJ (23PC19) and S Murali Krishna (23PC31).

On the deck it appears twice: the title slide, where a judge sees it before
anything else, and the closing slide, where they are looking when they write
their notes. In the README and the documentation it sits directly under the
title, above the fold.

Also removed a duplicate subtitle line the README picked up in the process --
it was carrying two competing one-line descriptions of the project, which is
one more than a reader needs.
</commit_message>
<xml_diff>
--- a/SBOMGuard-Presentation.pptx
+++ b/SBOMGuard-Presentation.pptx
@@ -2833,7 +2833,7 @@
         </p:nvSpPr>
         <p:spPr>
           <a:xfrm>
-            <a:off x="822960" y="5760720"/>
+            <a:off x="822960" y="5440680"/>
             <a:ext cx="10515600" cy="274320"/>
           </a:xfrm>
           <a:prstGeom prst="rect">
@@ -2872,34 +2872,73 @@
         </p:nvSpPr>
         <p:spPr>
           <a:xfrm>
-            <a:off x="822960" y="6080760"/>
-            <a:ext cx="10515600" cy="274320"/>
-          </a:xfrm>
-          <a:prstGeom prst="rect">
-            <a:avLst/>
-          </a:prstGeom>
-          <a:noFill/>
-          <a:ln/>
-        </p:spPr>
-        <p:txBody>
-          <a:bodyPr wrap="square" lIns="0" tIns="0" rIns="0" bIns="0" rtlCol="0" anchor="ctr"/>
-          <a:lstStyle/>
-          <a:p>
-            <a:pPr indent="0" marL="0">
-              <a:buNone/>
-            </a:pPr>
-            <a:r>
-              <a:rPr lang="en-US" sz="1200" b="1" dirty="0">
-                <a:solidFill>
-                  <a:srgbClr val="A89F92"/>
+            <a:off x="822960" y="5870448"/>
+            <a:ext cx="1828800" cy="256032"/>
+          </a:xfrm>
+          <a:prstGeom prst="rect">
+            <a:avLst/>
+          </a:prstGeom>
+          <a:noFill/>
+          <a:ln/>
+        </p:spPr>
+        <p:txBody>
+          <a:bodyPr wrap="square" lIns="0" tIns="0" rIns="0" bIns="0" rtlCol="0" anchor="ctr"/>
+          <a:lstStyle/>
+          <a:p>
+            <a:pPr indent="0" marL="0">
+              <a:buNone/>
+            </a:pPr>
+            <a:r>
+              <a:rPr lang="en-US" sz="1000" b="1" spc="200" kern="0" dirty="0">
+                <a:solidFill>
+                  <a:srgbClr val="7E766A"/>
                 </a:solidFill>
                 <a:latin typeface="Calibri" pitchFamily="34" charset="0"/>
                 <a:ea typeface="Calibri" pitchFamily="34" charset="-122"/>
                 <a:cs typeface="Calibri" pitchFamily="34" charset="-120"/>
               </a:rPr>
-              <a:t>Harish HJ   ·   github.com/harish-88279/SG-Hackathon</a:t>
-            </a:r>
-            <a:endParaRPr lang="en-US" sz="1200" dirty="0"/>
+              <a:t>SUBMITTED BY</a:t>
+            </a:r>
+            <a:endParaRPr lang="en-US" sz="1000" dirty="0"/>
+          </a:p>
+        </p:txBody>
+      </p:sp>
+      <p:sp>
+        <p:nvSpPr>
+          <p:cNvPr id="9" name="Text 7"/>
+          <p:cNvSpPr/>
+          <p:nvPr/>
+        </p:nvSpPr>
+        <p:spPr>
+          <a:xfrm>
+            <a:off x="822960" y="6144768"/>
+            <a:ext cx="7863840" cy="274320"/>
+          </a:xfrm>
+          <a:prstGeom prst="rect">
+            <a:avLst/>
+          </a:prstGeom>
+          <a:noFill/>
+          <a:ln/>
+        </p:spPr>
+        <p:txBody>
+          <a:bodyPr wrap="square" lIns="0" tIns="0" rIns="0" bIns="0" rtlCol="0" anchor="ctr"/>
+          <a:lstStyle/>
+          <a:p>
+            <a:pPr indent="0" marL="0">
+              <a:buNone/>
+            </a:pPr>
+            <a:r>
+              <a:rPr lang="en-US" sz="1300" b="1" dirty="0">
+                <a:solidFill>
+                  <a:srgbClr val="F2EEE7"/>
+                </a:solidFill>
+                <a:latin typeface="Calibri" pitchFamily="34" charset="0"/>
+                <a:ea typeface="Calibri" pitchFamily="34" charset="-122"/>
+                <a:cs typeface="Calibri" pitchFamily="34" charset="-120"/>
+              </a:rPr>
+              <a:t>Harish HJ  (23PC19)        S Murali Krishna  (23PC31)</a:t>
+            </a:r>
+            <a:endParaRPr lang="en-US" sz="1300" dirty="0"/>
           </a:p>
         </p:txBody>
       </p:sp>
@@ -4267,7 +4306,7 @@
                 <a:ea typeface="Calibri" pitchFamily="34" charset="-122"/>
                 <a:cs typeface="Calibri" pitchFamily="34" charset="-120"/>
               </a:rPr>
-              <a:t>REPOSITORY</a:t>
+              <a:t>SUBMITTED BY</a:t>
             </a:r>
             <a:endParaRPr lang="en-US" sz="1000" dirty="0"/>
           </a:p>
@@ -4306,7 +4345,7 @@
                 <a:ea typeface="Courier New" pitchFamily="34" charset="-122"/>
                 <a:cs typeface="Courier New" pitchFamily="34" charset="-120"/>
               </a:rPr>
-              <a:t>github.com/harish-88279/SG-Hackathon</a:t>
+              <a:t>Harish HJ (23PC19)   ·   S Murali Krishna (23PC31)</a:t>
             </a:r>
             <a:endParaRPr lang="en-US" sz="1150" dirty="0"/>
           </a:p>
@@ -4345,7 +4384,7 @@
                 <a:ea typeface="Calibri" pitchFamily="34" charset="-122"/>
                 <a:cs typeface="Calibri" pitchFamily="34" charset="-120"/>
               </a:rPr>
-              <a:t>DOCUMENTATION</a:t>
+              <a:t>REPOSITORY</a:t>
             </a:r>
             <a:endParaRPr lang="en-US" sz="1000" dirty="0"/>
           </a:p>
@@ -4384,7 +4423,7 @@
                 <a:ea typeface="Courier New" pitchFamily="34" charset="-122"/>
                 <a:cs typeface="Courier New" pitchFamily="34" charset="-120"/>
               </a:rPr>
-              <a:t>docs/DOCUMENTATION.md  ·  docs/DATA_DEFECT.md</a:t>
+              <a:t>github.com/harish-88279/SG-Hackathon</a:t>
             </a:r>
             <a:endParaRPr lang="en-US" sz="1150" dirty="0"/>
           </a:p>

</xml_diff>